<commit_message>
CR-18: fix silent TTS on mobile + retryable recording errors; fix TT 17/2025 citations
- speech.ts: deferred speak() after cancel(), watchdog surfaces silent failures
- pronunciation recording: error phase + "Thu lai" retry instead of swallowing errors
- marketing copy: TT 17/2025 applies to History/Geography/Civics, not English -
  corrected proposal generators, DOCX, landing copy and CR-14 notes

Generated with [Devin](https://devin.ai)

Co-Authored-By: Devin <158243242+devin-ai-integration[bot]@users.noreply.github.com>
</commit_message>
<xml_diff>
--- a/docs/proposal-vieschool-khach-hang.pptx
+++ b/docs/proposal-vieschool-khach-hang.pptx
@@ -4711,7 +4711,7 @@
                 </a:solidFill>
                 <a:latin typeface="Avenir Next"/>
               </a:rPr>
-              <a:t>Bám Global Success và CTGDPT 2018 (cập nhật TT 17/2025).</a:t>
+              <a:t>Bám SGK Tiếng Anh Global Success theo CTGDPT 2018.</a:t>
             </a:r>
           </a:p>
           <a:p>
@@ -7688,7 +7688,7 @@
                           </a:solidFill>
                           <a:latin typeface="Avenir Next"/>
                         </a:rPr>
-                        <a:t>CTGDPT 2018 (cập nhật TT 17/2025),</a:t>
+                        <a:t>CTGDPT 2018 (gồm sửa đổi của TT 17/2025</a:t>
                       </a:r>
                     </a:p>
                     <a:p>
@@ -7699,7 +7699,7 @@
                           </a:solidFill>
                           <a:latin typeface="Avenir Next"/>
                         </a:rPr>
-                        <a:t>gắn mã yêu cầu cần đạt</a:t>
+                        <a:t>cho Lịch sử, Địa lí, GDCD), gắn mã YCCĐ</a:t>
                       </a:r>
                     </a:p>
                   </a:txBody>

</xml_diff>

<commit_message>
Update customer proposal deck: per-grade exam claims, class code join, corrected pricing
Deck was regenerated pre CR-44..47 and carried stale facts: "200
cau/30 phut" style claims replaced with per-grade exam sizing, class
code join added to the user-guide slide, and English Arena pricing
aligned to docs/sales/01-pricing.md (family 249k/6mo - 399k/yr, class
group 199k/HS, school 99k/HS scaled). Dropped Math/Science TA claims -
those banks are not yet populated beyond Grade 2.

Generated with [Devin](https://devin.ai)

Co-Authored-By: Devin <158243242+devin-ai-integration[bot]@users.noreply.github.com>
</commit_message>
<xml_diff>
--- a/docs/proposal-vieschool-khach-hang.pptx
+++ b/docs/proposal-vieschool-khach-hang.pptx
@@ -3474,7 +3474,7 @@
         </p:nvGraphicFramePr>
         <p:xfrm>
           <a:off x="548640" y="1920240"/>
-          <a:ext cx="11064240" cy="2743200"/>
+          <a:ext cx="11064240" cy="3108960"/>
         </p:xfrm>
         <a:graphic>
           <a:graphicData uri="http://schemas.openxmlformats.org/drawingml/2006/table">
@@ -3487,7 +3487,7 @@
                 <a:gridCol w="3566160"/>
                 <a:gridCol w="5303520"/>
               </a:tblGrid>
-              <a:tr h="685800">
+              <a:tr h="621792">
                 <a:tc>
                   <a:txBody>
                     <a:bodyPr/>
@@ -3555,7 +3555,7 @@
                   </a:tcPr>
                 </a:tc>
               </a:tr>
-              <a:tr h="685800">
+              <a:tr h="621792">
                 <a:tc>
                   <a:txBody>
                     <a:bodyPr/>
@@ -3623,7 +3623,7 @@
                   </a:tcPr>
                 </a:tc>
               </a:tr>
-              <a:tr h="685800">
+              <a:tr h="621792">
                 <a:tc>
                   <a:txBody>
                     <a:bodyPr/>
@@ -3658,20 +3658,9 @@
                           </a:solidFill>
                           <a:latin typeface="Avenir Next"/>
                         </a:rPr>
-                        <a:t>249.000đ / học sinh / năm</a:t>
-                      </a:r>
-                    </a:p>
-                  </a:txBody>
-                  <a:tcPr marT="38100" marB="38100">
-                    <a:solidFill>
-                      <a:srgbClr val="121B33"/>
-                    </a:solidFill>
-                  </a:tcPr>
-                </a:tc>
-                <a:tc>
-                  <a:txBody>
-                    <a:bodyPr/>
-                    <a:lstStyle/>
+                        <a:t>249.000đ / 6 tháng</a:t>
+                      </a:r>
+                    </a:p>
                     <a:p>
                       <a:r>
                         <a:rPr sz="1300" b="0">
@@ -3680,6 +3669,28 @@
                           </a:solidFill>
                           <a:latin typeface="Avenir Next"/>
                         </a:rPr>
+                        <a:t>hoặc 399.000đ / năm</a:t>
+                      </a:r>
+                    </a:p>
+                  </a:txBody>
+                  <a:tcPr marT="38100" marB="38100">
+                    <a:solidFill>
+                      <a:srgbClr val="121B33"/>
+                    </a:solidFill>
+                  </a:tcPr>
+                </a:tc>
+                <a:tc>
+                  <a:txBody>
+                    <a:bodyPr/>
+                    <a:lstStyle/>
+                    <a:p>
+                      <a:r>
+                        <a:rPr sz="1300" b="0">
+                          <a:solidFill>
+                            <a:srgbClr val="F4F6FB"/>
+                          </a:solidFill>
+                          <a:latin typeface="Avenir Next"/>
+                        </a:rPr>
                         <a:t>Đủ 5 khối, đủ 4 vòng, lưu tiến độ và thành tích</a:t>
                       </a:r>
                     </a:p>
@@ -3691,7 +3702,7 @@
                   </a:tcPr>
                 </a:tc>
               </a:tr>
-              <a:tr h="685800">
+              <a:tr h="621792">
                 <a:tc>
                   <a:txBody>
                     <a:bodyPr/>
@@ -3704,6 +3715,74 @@
                           </a:solidFill>
                           <a:latin typeface="Avenir Next"/>
                         </a:rPr>
+                        <a:t>Nhóm lớp (PH mua)</a:t>
+                      </a:r>
+                    </a:p>
+                  </a:txBody>
+                  <a:tcPr marT="38100" marB="38100">
+                    <a:solidFill>
+                      <a:srgbClr val="121B33"/>
+                    </a:solidFill>
+                  </a:tcPr>
+                </a:tc>
+                <a:tc>
+                  <a:txBody>
+                    <a:bodyPr/>
+                    <a:lstStyle/>
+                    <a:p>
+                      <a:r>
+                        <a:rPr sz="1300" b="0">
+                          <a:solidFill>
+                            <a:srgbClr val="F4F6FB"/>
+                          </a:solidFill>
+                          <a:latin typeface="Avenir Next"/>
+                        </a:rPr>
+                        <a:t>199.000đ / học sinh / năm</a:t>
+                      </a:r>
+                    </a:p>
+                  </a:txBody>
+                  <a:tcPr marT="38100" marB="38100">
+                    <a:solidFill>
+                      <a:srgbClr val="121B33"/>
+                    </a:solidFill>
+                  </a:tcPr>
+                </a:tc>
+                <a:tc>
+                  <a:txBody>
+                    <a:bodyPr/>
+                    <a:lstStyle/>
+                    <a:p>
+                      <a:r>
+                        <a:rPr sz="1300" b="0">
+                          <a:solidFill>
+                            <a:srgbClr val="F4F6FB"/>
+                          </a:solidFill>
+                          <a:latin typeface="Avenir Next"/>
+                        </a:rPr>
+                        <a:t>Tối thiểu 15 học sinh; vào lớp tự phục vụ bằng mã lớp</a:t>
+                      </a:r>
+                    </a:p>
+                  </a:txBody>
+                  <a:tcPr marT="38100" marB="38100">
+                    <a:solidFill>
+                      <a:srgbClr val="121B33"/>
+                    </a:solidFill>
+                  </a:tcPr>
+                </a:tc>
+              </a:tr>
+              <a:tr h="621792">
+                <a:tc>
+                  <a:txBody>
+                    <a:bodyPr/>
+                    <a:lstStyle/>
+                    <a:p>
+                      <a:r>
+                        <a:rPr sz="1300" b="0">
+                          <a:solidFill>
+                            <a:srgbClr val="F4F6FB"/>
+                          </a:solidFill>
+                          <a:latin typeface="Avenir Next"/>
+                        </a:rPr>
                         <a:t>Nhà trường</a:t>
                       </a:r>
                     </a:p>
@@ -3726,20 +3805,9 @@
                           </a:solidFill>
                           <a:latin typeface="Avenir Next"/>
                         </a:rPr>
-                        <a:t>30.000 - 50.000đ / học sinh / năm</a:t>
-                      </a:r>
-                    </a:p>
-                  </a:txBody>
-                  <a:tcPr marT="38100" marB="38100">
-                    <a:solidFill>
-                      <a:srgbClr val="121B33"/>
-                    </a:solidFill>
-                  </a:tcPr>
-                </a:tc>
-                <a:tc>
-                  <a:txBody>
-                    <a:bodyPr/>
-                    <a:lstStyle/>
+                        <a:t>99.000đ / học sinh / năm</a:t>
+                      </a:r>
+                    </a:p>
                     <a:p>
                       <a:r>
                         <a:rPr sz="1300" b="0">
@@ -3748,7 +3816,29 @@
                           </a:solidFill>
                           <a:latin typeface="Avenir Next"/>
                         </a:rPr>
-                        <a:t>Theo quy mô; kèm console quản lý lớp và báo cáo</a:t>
+                        <a:t>(79.000đ từ 300 HS)</a:t>
+                      </a:r>
+                    </a:p>
+                  </a:txBody>
+                  <a:tcPr marT="38100" marB="38100">
+                    <a:solidFill>
+                      <a:srgbClr val="121B33"/>
+                    </a:solidFill>
+                  </a:tcPr>
+                </a:tc>
+                <a:tc>
+                  <a:txBody>
+                    <a:bodyPr/>
+                    <a:lstStyle/>
+                    <a:p>
+                      <a:r>
+                        <a:rPr sz="1300" b="0">
+                          <a:solidFill>
+                            <a:srgbClr val="F4F6FB"/>
+                          </a:solidFill>
+                          <a:latin typeface="Avenir Next"/>
+                        </a:rPr>
+                        <a:t>Console quản lý lớp, báo cáo; 800+ HS báo giá riêng</a:t>
                       </a:r>
                     </a:p>
                   </a:txBody>
@@ -6162,7 +6252,7 @@
                 </a:solidFill>
                 <a:latin typeface="Avenir Next"/>
               </a:rPr>
-              <a:t>4 vòng chơi mỗi bài</a:t>
+              <a:t>Luyện đề + Thi thử theo khối</a:t>
             </a:r>
           </a:p>
         </p:txBody>
@@ -6197,7 +6287,7 @@
                 </a:solidFill>
                 <a:latin typeface="Avenir Next"/>
               </a:rPr>
-              <a:t>Nghe - chọn đáp án - ghép cặp - phát âm có chấm điểm.</a:t>
+              <a:t>Đề luyện và thi thử theo format đề IOE - số câu và thời gian</a:t>
             </a:r>
           </a:p>
           <a:p>
@@ -6209,7 +6299,7 @@
                 </a:solidFill>
                 <a:latin typeface="Avenir Next"/>
               </a:rPr>
-              <a:t>Giọng đọc rõ, tốc độ chậm phù hợp trẻ nhỏ.</a:t>
+              <a:t>chỉnh riêng từng khối (lớp 1 nhẹ hơn lớp 5).</a:t>
             </a:r>
           </a:p>
         </p:txBody>
@@ -6290,7 +6380,7 @@
                 </a:solidFill>
                 <a:latin typeface="Avenir Next"/>
               </a:rPr>
-              <a:t>Phản hồi học tập</a:t>
+              <a:t>Thi đua có đối thủ</a:t>
             </a:r>
           </a:p>
         </p:txBody>
@@ -6325,7 +6415,7 @@
                 </a:solidFill>
                 <a:latin typeface="Avenir Next"/>
               </a:rPr>
-              <a:t>Trả lời sai vẫn được giải thích: đáp án đã chọn,</a:t>
+              <a:t>Bảng xếp hạng tuần theo khối, đấu trường 1v1, sao - huy hiệu -</a:t>
             </a:r>
           </a:p>
           <a:p>
@@ -6337,7 +6427,7 @@
                 </a:solidFill>
                 <a:latin typeface="Avenir Next"/>
               </a:rPr>
-              <a:t>đáp án đúng kèm nghĩa tiếng Việt - bé hiểu vì sao.</a:t>
+              <a:t>chuỗi ngày học. Tiến độ đồng bộ mọi thiết bị, không mất khi đổi máy.</a:t>
             </a:r>
           </a:p>
         </p:txBody>
@@ -6453,7 +6543,7 @@
                 </a:solidFill>
                 <a:latin typeface="Avenir Next"/>
               </a:rPr>
-              <a:t>Username + PIN do giáo viên cấp, học sinh tự đổi PIN.</a:t>
+              <a:t>Username + PIN do giáo viên cấp, học sinh tự đổi PIN. Vào lớp bằng</a:t>
             </a:r>
           </a:p>
           <a:p>
@@ -6465,7 +6555,7 @@
                 </a:solidFill>
                 <a:latin typeface="Avenir Next"/>
               </a:rPr>
-              <a:t>Không quảng cáo, không thu thập liên hệ trẻ em.</a:t>
+              <a:t>mã lớp 6 ký tự - không qua admin. Không quảng cáo, không chat.</a:t>
             </a:r>
           </a:p>
         </p:txBody>
@@ -9029,7 +9119,19 @@
                 </a:solidFill>
                 <a:latin typeface="Avenir Next"/>
               </a:rPr>
-              <a:t>- Quản trị: tạo tài khoản học sinh, gán phạm vi lớp, xem tiến độ.</a:t>
+              <a:t>- Vào lớp: nhập mã lớp 6 ký tự cô gửi (VD lớp demo: R8WHYF) - không cần admin gán tay.</a:t>
+            </a:r>
+          </a:p>
+          <a:p>
+            <a:pPr algn="l"/>
+            <a:r>
+              <a:rPr sz="1300" b="0">
+                <a:solidFill>
+                  <a:srgbClr val="F4F6FB"/>
+                </a:solidFill>
+                <a:latin typeface="Avenir Next"/>
+              </a:rPr>
+              <a:t>- Quản trị: tạo tài khoản học sinh, tạo lớp sinh mã tự động, gán phạm vi lớp, xem tiến độ.</a:t>
             </a:r>
           </a:p>
         </p:txBody>

</xml_diff>

<commit_message>
CR-54: refresh landing + customer proposal for V6 bank and 3-program scope
Marketing artifacts were describing the pre-V6 product (1100+ vocab,
stale per-grade pricing in the docx, "English only" weakness). Updated
to the verified current state: 11.400+ questions with Vietnamese
explanations, 270 blueprint exam forms, 3 English-medium programs,
practice timing, licensed visual assets. Docx is now generated by
gen-customer-proposal-doc.py so it cannot drift from the deck again.

Generated with [Devin](https://devin.ai)

Co-Authored-By: Devin <158243242+devin-ai-integration[bot]@users.noreply.github.com>
</commit_message>
<xml_diff>
--- a/docs/proposal-vieschool-khach-hang.pptx
+++ b/docs/proposal-vieschool-khach-hang.pptx
@@ -5721,7 +5721,7 @@
                           </a:solidFill>
                           <a:latin typeface="Avenir Next"/>
                         </a:rPr>
-                        <a:t>Luyện tiếng Anh bám SGK Global Success qua hành trình phiêu lưu</a:t>
+                        <a:t>Luyện Tiếng Anh, Toán và Khoa học tiếng Anh bám SGK Global Success</a:t>
                       </a:r>
                     </a:p>
                   </a:txBody>
@@ -6124,7 +6124,7 @@
                 </a:solidFill>
                 <a:latin typeface="Avenir Next"/>
               </a:rPr>
-              <a:t>1100+ từ vựng bám SGK</a:t>
+              <a:t>11.400+ câu hỏi có giải thích</a:t>
             </a:r>
           </a:p>
         </p:txBody>
@@ -6159,7 +6159,7 @@
                 </a:solidFill>
                 <a:latin typeface="Avenir Next"/>
               </a:rPr>
-              <a:t>Phủ Global Success lớp 1-5, mỗi từ có hình minh họa,</a:t>
+              <a:t>Bám SGK Global Success lớp 1-5 - mỗi câu kèm đáp án và giải thích</a:t>
             </a:r>
           </a:p>
           <a:p>
@@ -6171,7 +6171,7 @@
                 </a:solidFill>
                 <a:latin typeface="Avenir Next"/>
               </a:rPr>
-              <a:t>giải thích tiếng Việt, câu ví dụ được kiểm duyệt ngữ pháp.</a:t>
+              <a:t>tiếng Việt đã kiểm duyệt, hình minh họa bản quyền rõ ràng.</a:t>
             </a:r>
           </a:p>
         </p:txBody>
@@ -6252,7 +6252,7 @@
                 </a:solidFill>
                 <a:latin typeface="Avenir Next"/>
               </a:rPr>
-              <a:t>Luyện đề + Thi thử theo khối</a:t>
+              <a:t>270 đề thi + luyện đề theo khối</a:t>
             </a:r>
           </a:p>
         </p:txBody>
@@ -6287,7 +6287,7 @@
                 </a:solidFill>
                 <a:latin typeface="Avenir Next"/>
               </a:rPr>
-              <a:t>Đề luyện và thi thử theo format đề IOE - số câu và thời gian</a:t>
+              <a:t>Đề thi chuẩn theo format đề IOE - số câu và thời gian chỉnh riêng</a:t>
             </a:r>
           </a:p>
           <a:p>
@@ -6299,7 +6299,7 @@
                 </a:solidFill>
                 <a:latin typeface="Avenir Next"/>
               </a:rPr>
-              <a:t>chỉnh riêng từng khối (lớp 1 nhẹ hơn lớp 5).</a:t>
+              <a:t>từng khối. Ôn luyện có đồng hồ đo giờ, câu sai tự vào hàng đợi ôn lại.</a:t>
             </a:r>
           </a:p>
         </p:txBody>
@@ -6380,7 +6380,7 @@
                 </a:solidFill>
                 <a:latin typeface="Avenir Next"/>
               </a:rPr>
-              <a:t>Thi đua có đối thủ</a:t>
+              <a:t>3 môn luyện bằng tiếng Anh</a:t>
             </a:r>
           </a:p>
         </p:txBody>
@@ -6415,7 +6415,7 @@
                 </a:solidFill>
                 <a:latin typeface="Avenir Next"/>
               </a:rPr>
-              <a:t>Bảng xếp hạng tuần theo khối, đấu trường 1v1, sao - huy hiệu -</a:t>
+              <a:t>Tiếng Anh + Toán tiếng Anh + Khoa học tiếng Anh trong cùng app -</a:t>
             </a:r>
           </a:p>
           <a:p>
@@ -6427,7 +6427,7 @@
                 </a:solidFill>
                 <a:latin typeface="Avenir Next"/>
               </a:rPr>
-              <a:t>chuỗi ngày học. Tiến độ đồng bộ mọi thiết bị, không mất khi đổi máy.</a:t>
+              <a:t>đúng nhu cầu luyện IOE và Violympic của phụ huynh.</a:t>
             </a:r>
           </a:p>
         </p:txBody>
@@ -6508,7 +6508,7 @@
                 </a:solidFill>
                 <a:latin typeface="Avenir Next"/>
               </a:rPr>
-              <a:t>An toàn &amp; quản lý</a:t>
+              <a:t>Thi đua &amp; an toàn</a:t>
             </a:r>
           </a:p>
         </p:txBody>
@@ -6543,7 +6543,7 @@
                 </a:solidFill>
                 <a:latin typeface="Avenir Next"/>
               </a:rPr>
-              <a:t>Username + PIN do giáo viên cấp, học sinh tự đổi PIN. Vào lớp bằng</a:t>
+              <a:t>Bảng xếp hạng tuần, đấu trường 1v1, sao - huy hiệu - chuỗi ngày học.</a:t>
             </a:r>
           </a:p>
           <a:p>
@@ -6555,7 +6555,7 @@
                 </a:solidFill>
                 <a:latin typeface="Avenir Next"/>
               </a:rPr>
-              <a:t>mã lớp 6 ký tự - không qua admin. Không quảng cáo, không chat.</a:t>
+              <a:t>Vào lớp bằng mã 6 ký tự. Không quảng cáo, không chat.</a:t>
             </a:r>
           </a:p>
         </p:txBody>
@@ -6909,7 +6909,7 @@
                           </a:solidFill>
                           <a:latin typeface="Avenir Next"/>
                         </a:rPr>
-                        <a:t>mỗi từ gắn đúng bài học</a:t>
+                        <a:t>mỗi câu kèm giải thích tiếng Việt</a:t>
                       </a:r>
                     </a:p>
                   </a:txBody>
@@ -7089,7 +7089,7 @@
                           </a:solidFill>
                           <a:latin typeface="Avenir Next"/>
                         </a:rPr>
-                        <a:t>Kỹ năng luyện</a:t>
+                        <a:t>Môn luyện</a:t>
                       </a:r>
                     </a:p>
                   </a:txBody>
@@ -7111,7 +7111,7 @@
                           </a:solidFill>
                           <a:latin typeface="Avenir Next"/>
                         </a:rPr>
-                        <a:t>Nghe - đọc - ghép cặp -</a:t>
+                        <a:t>Tiếng Anh + Toán tiếng Anh +</a:t>
                       </a:r>
                     </a:p>
                     <a:p>
@@ -7122,7 +7122,7 @@
                           </a:solidFill>
                           <a:latin typeface="Avenir Next"/>
                         </a:rPr>
-                        <a:t>phát âm chấm điểm</a:t>
+                        <a:t>Khoa học tiếng Anh</a:t>
                       </a:r>
                     </a:p>
                   </a:txBody>
@@ -7144,9 +7144,20 @@
                           </a:solidFill>
                           <a:latin typeface="Avenir Next"/>
                         </a:rPr>
-                        <a:t>Nghe - đọc - nói</a:t>
-                      </a:r>
-                    </a:p>
+                        <a:t>Chủ yếu tiếng Anh/ngôn ngữ</a:t>
+                      </a:r>
+                    </a:p>
+                  </a:txBody>
+                  <a:tcPr marT="38100" marB="38100">
+                    <a:solidFill>
+                      <a:srgbClr val="121B33"/>
+                    </a:solidFill>
+                  </a:tcPr>
+                </a:tc>
+                <a:tc>
+                  <a:txBody>
+                    <a:bodyPr/>
+                    <a:lstStyle/>
                     <a:p>
                       <a:r>
                         <a:rPr sz="1100" b="0">
@@ -7155,20 +7166,9 @@
                           </a:solidFill>
                           <a:latin typeface="Avenir Next"/>
                         </a:rPr>
-                        <a:t>(chấm phát âm tốt)</a:t>
-                      </a:r>
-                    </a:p>
-                  </a:txBody>
-                  <a:tcPr marT="38100" marB="38100">
-                    <a:solidFill>
-                      <a:srgbClr val="121B33"/>
-                    </a:solidFill>
-                  </a:tcPr>
-                </a:tc>
-                <a:tc>
-                  <a:txBody>
-                    <a:bodyPr/>
-                    <a:lstStyle/>
+                        <a:t>Tách nhiều app/gói</a:t>
+                      </a:r>
+                    </a:p>
                     <a:p>
                       <a:r>
                         <a:rPr sz="1100" b="0">
@@ -7177,7 +7177,7 @@
                           </a:solidFill>
                           <a:latin typeface="Avenir Next"/>
                         </a:rPr>
-                        <a:t>Chủ yếu đọc/nghe trắc nghiệm</a:t>
+                        <a:t>cho từng môn</a:t>
                       </a:r>
                     </a:p>
                   </a:txBody>
@@ -7447,7 +7447,7 @@
                           </a:solidFill>
                           <a:latin typeface="Avenir Next"/>
                         </a:rPr>
-                        <a:t>Chỉ tiếng Anh, mới phủ lớp 1-5;</a:t>
+                        <a:t>Mới phủ lớp 1-5 (lộ trình 6-12);</a:t>
                       </a:r>
                     </a:p>
                     <a:p>
@@ -9108,6 +9108,18 @@
                 <a:latin typeface="Avenir Next"/>
               </a:rPr>
               <a:t>- Học sinh: đăng nhập username + PIN do giáo viên cấp, tự đổi PIN khi cần.</a:t>
+            </a:r>
+          </a:p>
+          <a:p>
+            <a:pPr algn="l"/>
+            <a:r>
+              <a:rPr sz="1300" b="0">
+                <a:solidFill>
+                  <a:srgbClr val="F4F6FB"/>
+                </a:solidFill>
+                <a:latin typeface="Avenir Next"/>
+              </a:rPr>
+              <a:t>- Chọn khối - chọn môn (Tiếng Anh / Toán / Khoa học) - Luyện đề có đồng hồ đo giờ, Thi thử đếm ngược.</a:t>
             </a:r>
           </a:p>
           <a:p>

</xml_diff>